<commit_message>
Close QueryPilot MVP release candidate
</commit_message>
<xml_diff>
--- a/artifacts/QueryPilot_Local_Teknik_Sunum.pptx
+++ b/artifacts/QueryPilot_Local_Teknik_Sunum.pptx
@@ -2,18 +2,18 @@
 <file path=ppt/presentation.xml><?xml version="1.0" encoding="utf-8"?>
 <p:presentation xmlns:p="http://schemas.openxmlformats.org/presentationml/2006/main">
   <p:sldMasterIdLst>
-    <p:sldMasterId xmlns:r="http://schemas.openxmlformats.org/officeDocument/2006/relationships" id="2147483648" r:id="R9cfb208d7e0145b2"/>
+    <p:sldMasterId xmlns:r="http://schemas.openxmlformats.org/officeDocument/2006/relationships" id="2147483648" r:id="Rd0d8c8f28276451e"/>
   </p:sldMasterIdLst>
   <p:notesMasterIdLst>
-    <p:notesMasterId xmlns:r="http://schemas.openxmlformats.org/officeDocument/2006/relationships" r:id="Rbc5004135c51403d"/>
+    <p:notesMasterId xmlns:r="http://schemas.openxmlformats.org/officeDocument/2006/relationships" r:id="R6e1aedb70a1a4148"/>
   </p:notesMasterIdLst>
   <p:sldIdLst>
-    <p:sldId xmlns:r="http://schemas.openxmlformats.org/officeDocument/2006/relationships" id="256" r:id="R0d094784441a47d0"/>
-    <p:sldId xmlns:r="http://schemas.openxmlformats.org/officeDocument/2006/relationships" id="257" r:id="R0d43946da54b4cc8"/>
-    <p:sldId xmlns:r="http://schemas.openxmlformats.org/officeDocument/2006/relationships" id="258" r:id="R2e7cb739512f4406"/>
-    <p:sldId xmlns:r="http://schemas.openxmlformats.org/officeDocument/2006/relationships" id="259" r:id="R665ba90691984343"/>
-    <p:sldId xmlns:r="http://schemas.openxmlformats.org/officeDocument/2006/relationships" id="260" r:id="Rae22be0bd5524a1f"/>
-    <p:sldId xmlns:r="http://schemas.openxmlformats.org/officeDocument/2006/relationships" id="261" r:id="R0677f9c9b60f4da5"/>
+    <p:sldId xmlns:r="http://schemas.openxmlformats.org/officeDocument/2006/relationships" id="256" r:id="R31014305a5ad4b9f"/>
+    <p:sldId xmlns:r="http://schemas.openxmlformats.org/officeDocument/2006/relationships" id="257" r:id="Rc8ff9f2b361b455d"/>
+    <p:sldId xmlns:r="http://schemas.openxmlformats.org/officeDocument/2006/relationships" id="258" r:id="Rb0b132a5712d43a7"/>
+    <p:sldId xmlns:r="http://schemas.openxmlformats.org/officeDocument/2006/relationships" id="259" r:id="R19261e963aa44bbc"/>
+    <p:sldId xmlns:r="http://schemas.openxmlformats.org/officeDocument/2006/relationships" id="260" r:id="R2fc0b1b4b8bc444b"/>
+    <p:sldId xmlns:r="http://schemas.openxmlformats.org/officeDocument/2006/relationships" id="261" r:id="Ra398c870c4354796"/>
   </p:sldIdLst>
   <p:sldSz cx="12192000" cy="6858000"/>
   <p:notesSz cx="6858000" cy="9144000"/>
@@ -902,7 +902,7 @@
           <a:lstStyle xmlns:a="http://schemas.openxmlformats.org/drawingml/2006/main"/>
           <a:p xmlns:a="http://schemas.openxmlformats.org/drawingml/2006/main">
             <a:r>
-              <a:t>Close on the remaining release work, not a generic thank-you. The tag is deliberately held until the reviewed evidence package is complete.</a:t>
+              <a:t>Close with the measured plan change, then state the boundary: this is a local synthetic fixture, not a production performance guarantee. The five-minute demo video remains the final manual release artefact.</a:t>
             </a:r>
           </a:p>
           <a:p xmlns:a="http://schemas.openxmlformats.org/drawingml/2006/main">
@@ -917,12 +917,17 @@
           </a:p>
           <a:p xmlns:a="http://schemas.openxmlformats.org/drawingml/2006/main">
             <a:r>
+              <a:t>- C:\Users\Eray\SEZAR\PROJECTS\QueryPilot\evaluation\before_after_benchmark.json</a:t>
+            </a:r>
+          </a:p>
+          <a:p xmlns:a="http://schemas.openxmlformats.org/drawingml/2006/main">
+            <a:r>
               <a:t>- C:\Users\Eray\SEZAR\PROJECTS\QueryPilot\docs\demo-script.md</a:t>
             </a:r>
           </a:p>
           <a:p xmlns:a="http://schemas.openxmlformats.org/drawingml/2006/main">
             <a:r>
-              <a:t>- C:\Users\Eray\SEZAR\PROJECTS\QueryPilot\docs\release-checklist.md</a:t>
+              <a:t>- C:\Users\Eray\SEZAR\PROJECTS\QueryPilot\docs\architecture.md</a:t>
             </a:r>
           </a:p>
         </p:txBody>
@@ -990,7 +995,7 @@
   </p:cSld>
   <p:clrMap bg1="lt1" tx1="dk1" bg2="lt2" tx2="dk2" accent1="accent1" accent2="accent2" accent3="accent3" accent4="accent4" accent5="accent5" accent6="accent6" hlink="hlink" folHlink="folHlink"/>
   <p:sldLayoutIdLst>
-    <p:sldLayoutId xmlns:r="http://schemas.openxmlformats.org/officeDocument/2006/relationships" id="2147483649" r:id="R0eff4062a13e4bfb"/>
+    <p:sldLayoutId xmlns:r="http://schemas.openxmlformats.org/officeDocument/2006/relationships" id="2147483649" r:id="Rd9bfae554d434a20"/>
   </p:sldLayoutIdLst>
   <p:txStyles>
     <p:titleStyle>
@@ -1559,6 +1564,7 @@
           <a:lstStyle xmlns:a="http://schemas.openxmlformats.org/drawingml/2006/main"/>
           <a:p xmlns:a="http://schemas.openxmlformats.org/drawingml/2006/main">
             <a:pPr algn="l">
+              <a:buNone/>
               <a:defRPr sz="6000">
                 <a:solidFill>
                   <a:srgbClr val="000000"/>
@@ -1605,6 +1611,7 @@
           <a:lstStyle xmlns:a="http://schemas.openxmlformats.org/drawingml/2006/main"/>
           <a:p xmlns:a="http://schemas.openxmlformats.org/drawingml/2006/main">
             <a:pPr algn="l">
+              <a:buNone/>
               <a:defRPr sz="2400">
                 <a:solidFill>
                   <a:srgbClr val="000000"/>
@@ -1650,6 +1657,7 @@
           <a:lstStyle xmlns:a="http://schemas.openxmlformats.org/drawingml/2006/main"/>
           <a:p xmlns:a="http://schemas.openxmlformats.org/drawingml/2006/main">
             <a:pPr algn="l">
+              <a:buNone/>
               <a:defRPr sz="2400">
                 <a:solidFill>
                   <a:srgbClr val="000000"/>
@@ -1746,6 +1754,7 @@
           <a:lstStyle xmlns:a="http://schemas.openxmlformats.org/drawingml/2006/main"/>
           <a:p xmlns:a="http://schemas.openxmlformats.org/drawingml/2006/main">
             <a:pPr algn="r">
+              <a:buNone/>
               <a:defRPr sz="1000">
                 <a:solidFill>
                   <a:srgbClr val="000000"/>
@@ -1791,6 +1800,7 @@
           <a:lstStyle xmlns:a="http://schemas.openxmlformats.org/drawingml/2006/main"/>
           <a:p xmlns:a="http://schemas.openxmlformats.org/drawingml/2006/main">
             <a:pPr algn="l">
+              <a:buNone/>
               <a:defRPr sz="2900">
                 <a:solidFill>
                   <a:srgbClr val="000000"/>
@@ -1808,7 +1818,7 @@
       </p:sp>
       <p:cxnSp>
         <p:nvCxnSpPr>
-          <p:cNvPr id="16" name="Google-Shape-2259-p159-4"/>
+          <p:cNvPr id="22" name="Google-Shape-2259-p159-4"/>
           <p:cNvCxnSpPr/>
           <p:nvPr/>
         </p:nvCxnSpPr>
@@ -1939,6 +1949,7 @@
           <a:lstStyle xmlns:a="http://schemas.openxmlformats.org/drawingml/2006/main"/>
           <a:p xmlns:a="http://schemas.openxmlformats.org/drawingml/2006/main">
             <a:pPr algn="l">
+              <a:buNone/>
               <a:defRPr sz="1600">
                 <a:solidFill>
                   <a:srgbClr val="000000"/>
@@ -1984,6 +1995,7 @@
           <a:lstStyle xmlns:a="http://schemas.openxmlformats.org/drawingml/2006/main"/>
           <a:p xmlns:a="http://schemas.openxmlformats.org/drawingml/2006/main">
             <a:pPr algn="l">
+              <a:buNone/>
               <a:defRPr sz="1600">
                 <a:solidFill>
                   <a:srgbClr val="000000"/>
@@ -2029,6 +2041,7 @@
           <a:lstStyle xmlns:a="http://schemas.openxmlformats.org/drawingml/2006/main"/>
           <a:p xmlns:a="http://schemas.openxmlformats.org/drawingml/2006/main">
             <a:pPr algn="l">
+              <a:buNone/>
               <a:defRPr sz="1600">
                 <a:solidFill>
                   <a:srgbClr val="000000"/>
@@ -2074,6 +2087,7 @@
           <a:lstStyle xmlns:a="http://schemas.openxmlformats.org/drawingml/2006/main"/>
           <a:p xmlns:a="http://schemas.openxmlformats.org/drawingml/2006/main">
             <a:pPr algn="l">
+              <a:buNone/>
               <a:defRPr sz="2400">
                 <a:solidFill>
                   <a:srgbClr val="000000"/>
@@ -2090,6 +2104,7 @@
           </a:p>
           <a:p xmlns:a="http://schemas.openxmlformats.org/drawingml/2006/main">
             <a:pPr algn="l">
+              <a:buNone/>
               <a:defRPr sz="2400">
                 <a:solidFill>
                   <a:srgbClr val="000000"/>
@@ -2135,6 +2150,7 @@
           <a:lstStyle xmlns:a="http://schemas.openxmlformats.org/drawingml/2006/main"/>
           <a:p xmlns:a="http://schemas.openxmlformats.org/drawingml/2006/main">
             <a:pPr algn="l">
+              <a:buNone/>
               <a:defRPr sz="2400">
                 <a:solidFill>
                   <a:srgbClr val="000000"/>
@@ -2151,6 +2167,7 @@
           </a:p>
           <a:p xmlns:a="http://schemas.openxmlformats.org/drawingml/2006/main">
             <a:pPr algn="l">
+              <a:buNone/>
               <a:defRPr sz="2400">
                 <a:solidFill>
                   <a:srgbClr val="000000"/>
@@ -2196,6 +2213,7 @@
           <a:lstStyle xmlns:a="http://schemas.openxmlformats.org/drawingml/2006/main"/>
           <a:p xmlns:a="http://schemas.openxmlformats.org/drawingml/2006/main">
             <a:pPr algn="l">
+              <a:buNone/>
               <a:defRPr sz="2400">
                 <a:solidFill>
                   <a:srgbClr val="000000"/>
@@ -2212,6 +2230,7 @@
           </a:p>
           <a:p xmlns:a="http://schemas.openxmlformats.org/drawingml/2006/main">
             <a:pPr algn="l">
+              <a:buNone/>
               <a:defRPr sz="2400">
                 <a:solidFill>
                   <a:srgbClr val="000000"/>
@@ -2310,6 +2329,7 @@
           <a:lstStyle xmlns:a="http://schemas.openxmlformats.org/drawingml/2006/main"/>
           <a:p xmlns:a="http://schemas.openxmlformats.org/drawingml/2006/main">
             <a:pPr algn="r">
+              <a:buNone/>
               <a:defRPr sz="1000">
                 <a:solidFill>
                   <a:srgbClr val="000000"/>
@@ -2355,6 +2375,7 @@
           <a:lstStyle xmlns:a="http://schemas.openxmlformats.org/drawingml/2006/main"/>
           <a:p xmlns:a="http://schemas.openxmlformats.org/drawingml/2006/main">
             <a:pPr algn="l">
+              <a:buNone/>
               <a:defRPr sz="2900">
                 <a:solidFill>
                   <a:srgbClr val="000000"/>
@@ -2400,6 +2421,7 @@
           <a:lstStyle xmlns:a="http://schemas.openxmlformats.org/drawingml/2006/main"/>
           <a:p xmlns:a="http://schemas.openxmlformats.org/drawingml/2006/main">
             <a:pPr algn="l">
+              <a:buNone/>
               <a:defRPr sz="2400">
                 <a:solidFill>
                   <a:srgbClr val="000000"/>
@@ -2445,6 +2467,7 @@
           <a:lstStyle xmlns:a="http://schemas.openxmlformats.org/drawingml/2006/main"/>
           <a:p xmlns:a="http://schemas.openxmlformats.org/drawingml/2006/main">
             <a:pPr algn="l">
+              <a:buNone/>
               <a:defRPr sz="2400">
                 <a:solidFill>
                   <a:srgbClr val="000000"/>
@@ -2490,6 +2513,7 @@
           <a:lstStyle xmlns:a="http://schemas.openxmlformats.org/drawingml/2006/main"/>
           <a:p xmlns:a="http://schemas.openxmlformats.org/drawingml/2006/main">
             <a:pPr algn="l">
+              <a:buNone/>
               <a:defRPr sz="2400">
                 <a:solidFill>
                   <a:srgbClr val="000000"/>
@@ -2535,6 +2559,7 @@
           <a:lstStyle xmlns:a="http://schemas.openxmlformats.org/drawingml/2006/main"/>
           <a:p xmlns:a="http://schemas.openxmlformats.org/drawingml/2006/main">
             <a:pPr algn="l">
+              <a:buNone/>
               <a:defRPr sz="2400">
                 <a:solidFill>
                   <a:srgbClr val="000000"/>
@@ -2580,6 +2605,7 @@
           <a:lstStyle xmlns:a="http://schemas.openxmlformats.org/drawingml/2006/main"/>
           <a:p xmlns:a="http://schemas.openxmlformats.org/drawingml/2006/main">
             <a:pPr algn="l">
+              <a:buNone/>
               <a:defRPr sz="2400">
                 <a:solidFill>
                   <a:srgbClr val="000000"/>
@@ -2625,6 +2651,7 @@
           <a:lstStyle xmlns:a="http://schemas.openxmlformats.org/drawingml/2006/main"/>
           <a:p xmlns:a="http://schemas.openxmlformats.org/drawingml/2006/main">
             <a:pPr algn="l">
+              <a:buNone/>
               <a:defRPr sz="2400">
                 <a:solidFill>
                   <a:srgbClr val="000000"/>
@@ -2670,6 +2697,7 @@
           <a:lstStyle xmlns:a="http://schemas.openxmlformats.org/drawingml/2006/main"/>
           <a:p xmlns:a="http://schemas.openxmlformats.org/drawingml/2006/main">
             <a:pPr algn="l">
+              <a:buNone/>
               <a:defRPr sz="2400">
                 <a:solidFill>
                   <a:srgbClr val="000000"/>
@@ -2715,6 +2743,7 @@
           <a:lstStyle xmlns:a="http://schemas.openxmlformats.org/drawingml/2006/main"/>
           <a:p xmlns:a="http://schemas.openxmlformats.org/drawingml/2006/main">
             <a:pPr algn="l">
+              <a:buNone/>
               <a:defRPr sz="2400">
                 <a:solidFill>
                   <a:srgbClr val="000000"/>
@@ -2760,6 +2789,7 @@
           <a:lstStyle xmlns:a="http://schemas.openxmlformats.org/drawingml/2006/main"/>
           <a:p xmlns:a="http://schemas.openxmlformats.org/drawingml/2006/main">
             <a:pPr algn="l">
+              <a:buNone/>
               <a:defRPr sz="2400">
                 <a:solidFill>
                   <a:srgbClr val="000000"/>
@@ -2776,6 +2806,7 @@
           </a:p>
           <a:p xmlns:a="http://schemas.openxmlformats.org/drawingml/2006/main">
             <a:pPr algn="l">
+              <a:buNone/>
               <a:defRPr sz="2400">
                 <a:solidFill>
                   <a:srgbClr val="000000"/>
@@ -2792,6 +2823,7 @@
           </a:p>
           <a:p xmlns:a="http://schemas.openxmlformats.org/drawingml/2006/main">
             <a:pPr algn="l">
+              <a:buNone/>
               <a:defRPr sz="2400">
                 <a:solidFill>
                   <a:srgbClr val="000000"/>
@@ -2891,6 +2923,7 @@
           <a:lstStyle xmlns:a="http://schemas.openxmlformats.org/drawingml/2006/main"/>
           <a:p xmlns:a="http://schemas.openxmlformats.org/drawingml/2006/main">
             <a:pPr algn="r">
+              <a:buNone/>
               <a:defRPr sz="1000">
                 <a:solidFill>
                   <a:srgbClr val="000000"/>
@@ -2936,6 +2969,7 @@
           <a:lstStyle xmlns:a="http://schemas.openxmlformats.org/drawingml/2006/main"/>
           <a:p xmlns:a="http://schemas.openxmlformats.org/drawingml/2006/main">
             <a:pPr algn="l">
+              <a:buNone/>
               <a:defRPr sz="2900">
                 <a:solidFill>
                   <a:srgbClr val="000000"/>
@@ -2981,6 +3015,7 @@
           <a:lstStyle xmlns:a="http://schemas.openxmlformats.org/drawingml/2006/main"/>
           <a:p xmlns:a="http://schemas.openxmlformats.org/drawingml/2006/main">
             <a:pPr algn="l">
+              <a:buNone/>
               <a:defRPr sz="2400">
                 <a:solidFill>
                   <a:srgbClr val="000000"/>
@@ -3026,6 +3061,7 @@
           <a:lstStyle xmlns:a="http://schemas.openxmlformats.org/drawingml/2006/main"/>
           <a:p xmlns:a="http://schemas.openxmlformats.org/drawingml/2006/main">
             <a:pPr algn="l">
+              <a:buNone/>
               <a:defRPr sz="2400">
                 <a:solidFill>
                   <a:srgbClr val="000000"/>
@@ -3195,6 +3231,7 @@
           <a:lstStyle xmlns:a="http://schemas.openxmlformats.org/drawingml/2006/main"/>
           <a:p xmlns:a="http://schemas.openxmlformats.org/drawingml/2006/main">
             <a:pPr algn="l">
+              <a:buNone/>
               <a:defRPr sz="1800">
                 <a:solidFill>
                   <a:srgbClr val="000000"/>
@@ -3210,6 +3247,7 @@
           </a:p>
           <a:p xmlns:a="http://schemas.openxmlformats.org/drawingml/2006/main">
             <a:pPr algn="l">
+              <a:buNone/>
               <a:defRPr sz="1800">
                 <a:solidFill>
                   <a:srgbClr val="000000"/>
@@ -3255,6 +3293,7 @@
           <a:lstStyle xmlns:a="http://schemas.openxmlformats.org/drawingml/2006/main"/>
           <a:p xmlns:a="http://schemas.openxmlformats.org/drawingml/2006/main">
             <a:pPr algn="l">
+              <a:buNone/>
               <a:defRPr sz="2400">
                 <a:solidFill>
                   <a:srgbClr val="000000"/>
@@ -3424,6 +3463,7 @@
           <a:lstStyle xmlns:a="http://schemas.openxmlformats.org/drawingml/2006/main"/>
           <a:p xmlns:a="http://schemas.openxmlformats.org/drawingml/2006/main">
             <a:pPr algn="l">
+              <a:buNone/>
               <a:defRPr sz="2400">
                 <a:solidFill>
                   <a:srgbClr val="000000"/>
@@ -3593,6 +3633,7 @@
           <a:lstStyle xmlns:a="http://schemas.openxmlformats.org/drawingml/2006/main"/>
           <a:p xmlns:a="http://schemas.openxmlformats.org/drawingml/2006/main">
             <a:pPr algn="l">
+              <a:buNone/>
               <a:defRPr sz="2400">
                 <a:solidFill>
                   <a:srgbClr val="000000"/>
@@ -3762,6 +3803,7 @@
           <a:lstStyle xmlns:a="http://schemas.openxmlformats.org/drawingml/2006/main"/>
           <a:p xmlns:a="http://schemas.openxmlformats.org/drawingml/2006/main">
             <a:pPr algn="l">
+              <a:buNone/>
               <a:defRPr sz="2400">
                 <a:solidFill>
                   <a:srgbClr val="000000"/>
@@ -4069,6 +4111,7 @@
           <a:lstStyle xmlns:a="http://schemas.openxmlformats.org/drawingml/2006/main"/>
           <a:p xmlns:a="http://schemas.openxmlformats.org/drawingml/2006/main">
             <a:pPr algn="r">
+              <a:buNone/>
               <a:defRPr sz="1000">
                 <a:solidFill>
                   <a:srgbClr val="000000"/>
@@ -4114,6 +4157,7 @@
           <a:lstStyle xmlns:a="http://schemas.openxmlformats.org/drawingml/2006/main"/>
           <a:p xmlns:a="http://schemas.openxmlformats.org/drawingml/2006/main">
             <a:pPr algn="l">
+              <a:buNone/>
               <a:defRPr sz="2900">
                 <a:solidFill>
                   <a:srgbClr val="000000"/>
@@ -4159,6 +4203,7 @@
           <a:lstStyle xmlns:a="http://schemas.openxmlformats.org/drawingml/2006/main"/>
           <a:p xmlns:a="http://schemas.openxmlformats.org/drawingml/2006/main">
             <a:pPr algn="l">
+              <a:buNone/>
               <a:defRPr sz="2400">
                 <a:solidFill>
                   <a:srgbClr val="000000"/>
@@ -4205,6 +4250,7 @@
           <a:lstStyle xmlns:a="http://schemas.openxmlformats.org/drawingml/2006/main"/>
           <a:p xmlns:a="http://schemas.openxmlformats.org/drawingml/2006/main">
             <a:pPr algn="l">
+              <a:buNone/>
               <a:defRPr sz="2400">
                 <a:solidFill>
                   <a:srgbClr val="000000"/>
@@ -4251,6 +4297,7 @@
           <a:lstStyle xmlns:a="http://schemas.openxmlformats.org/drawingml/2006/main"/>
           <a:p xmlns:a="http://schemas.openxmlformats.org/drawingml/2006/main">
             <a:pPr algn="l">
+              <a:buNone/>
               <a:defRPr sz="2400">
                 <a:solidFill>
                   <a:srgbClr val="000000"/>
@@ -4297,6 +4344,7 @@
           <a:lstStyle xmlns:a="http://schemas.openxmlformats.org/drawingml/2006/main"/>
           <a:p xmlns:a="http://schemas.openxmlformats.org/drawingml/2006/main">
             <a:pPr algn="l">
+              <a:buNone/>
               <a:defRPr sz="2400">
                 <a:solidFill>
                   <a:srgbClr val="000000"/>
@@ -4342,6 +4390,7 @@
           <a:lstStyle xmlns:a="http://schemas.openxmlformats.org/drawingml/2006/main"/>
           <a:p xmlns:a="http://schemas.openxmlformats.org/drawingml/2006/main">
             <a:pPr algn="l">
+              <a:buNone/>
               <a:defRPr sz="2400">
                 <a:solidFill>
                   <a:srgbClr val="000000"/>
@@ -4387,6 +4436,7 @@
           <a:lstStyle xmlns:a="http://schemas.openxmlformats.org/drawingml/2006/main"/>
           <a:p xmlns:a="http://schemas.openxmlformats.org/drawingml/2006/main">
             <a:pPr algn="l">
+              <a:buNone/>
               <a:defRPr sz="2400">
                 <a:solidFill>
                   <a:srgbClr val="000000"/>
@@ -4432,6 +4482,7 @@
           <a:lstStyle xmlns:a="http://schemas.openxmlformats.org/drawingml/2006/main"/>
           <a:p xmlns:a="http://schemas.openxmlformats.org/drawingml/2006/main">
             <a:pPr algn="l">
+              <a:buNone/>
               <a:defRPr sz="1600">
                 <a:solidFill>
                   <a:srgbClr val="000000"/>
@@ -4448,6 +4499,7 @@
           </a:p>
           <a:p xmlns:a="http://schemas.openxmlformats.org/drawingml/2006/main">
             <a:pPr algn="l">
+              <a:buNone/>
               <a:defRPr sz="1600">
                 <a:solidFill>
                   <a:srgbClr val="000000"/>
@@ -4546,6 +4598,7 @@
           <a:lstStyle xmlns:a="http://schemas.openxmlformats.org/drawingml/2006/main"/>
           <a:p xmlns:a="http://schemas.openxmlformats.org/drawingml/2006/main">
             <a:pPr algn="l">
+              <a:buNone/>
               <a:defRPr sz="6000">
                 <a:solidFill>
                   <a:srgbClr val="000000"/>
@@ -4556,8 +4609,8 @@
               </a:defRPr>
             </a:pPr>
             <a:r>
-              <a:t>Ship the proof,
-then tag v1.0.0</a:t>
+              <a:t>Proof measured.
+Limits explicit.</a:t>
             </a:r>
           </a:p>
         </p:txBody>
@@ -4592,6 +4645,7 @@
           <a:lstStyle xmlns:a="http://schemas.openxmlformats.org/drawingml/2006/main"/>
           <a:p xmlns:a="http://schemas.openxmlformats.org/drawingml/2006/main">
             <a:pPr algn="l">
+              <a:buNone/>
               <a:defRPr sz="1800">
                 <a:solidFill>
                   <a:srgbClr val="000000"/>
@@ -4602,11 +4656,12 @@
               </a:defRPr>
             </a:pPr>
             <a:r>
-              <a:t>querypilot.eraykulkizaga.com</a:t>
+              <a:t>1.671 ms Seq Scan → 0.074 ms Index Scan (7-run medians)</a:t>
             </a:r>
           </a:p>
           <a:p xmlns:a="http://schemas.openxmlformats.org/drawingml/2006/main">
             <a:pPr algn="l">
+              <a:buNone/>
               <a:defRPr sz="1800">
                 <a:solidFill>
                   <a:srgbClr val="000000"/>
@@ -4617,11 +4672,12 @@
               </a:defRPr>
             </a:pPr>
             <a:r>
-              <a:t>Next: screenshots + five-minute video</a:t>
+              <a:t>Local fixture only · optional CPU enrichment</a:t>
             </a:r>
           </a:p>
           <a:p xmlns:a="http://schemas.openxmlformats.org/drawingml/2006/main">
             <a:pPr algn="l">
+              <a:buNone/>
               <a:defRPr sz="1800">
                 <a:solidFill>
                   <a:srgbClr val="000000"/>
@@ -4632,7 +4688,7 @@
               </a:defRPr>
             </a:pPr>
             <a:r>
-              <a:t>Then: reviewed v1.0.0 release</a:t>
+              <a:t>Next: tool-calling v2 · querypilot.eraykulkizaga.com</a:t>
             </a:r>
           </a:p>
         </p:txBody>
@@ -4667,6 +4723,7 @@
           <a:lstStyle xmlns:a="http://schemas.openxmlformats.org/drawingml/2006/main"/>
           <a:p xmlns:a="http://schemas.openxmlformats.org/drawingml/2006/main">
             <a:pPr algn="l">
+              <a:buNone/>
               <a:defRPr sz="2400">
                 <a:solidFill>
                   <a:srgbClr val="000000"/>
@@ -4677,7 +4734,7 @@
               </a:defRPr>
             </a:pPr>
             <a:r>
-              <a:t>NEXT</a:t>
+              <a:t>EVIDENCE</a:t>
             </a:r>
           </a:p>
         </p:txBody>

</xml_diff>

<commit_message>
Release grounded AI beta 2
</commit_message>
<xml_diff>
--- a/artifacts/QueryPilot_Local_Teknik_Sunum.pptx
+++ b/artifacts/QueryPilot_Local_Teknik_Sunum.pptx
@@ -2,18 +2,18 @@
 <file path=ppt/presentation.xml><?xml version="1.0" encoding="utf-8"?>
 <p:presentation xmlns:p="http://schemas.openxmlformats.org/presentationml/2006/main">
   <p:sldMasterIdLst>
-    <p:sldMasterId xmlns:r="http://schemas.openxmlformats.org/officeDocument/2006/relationships" id="2147483648" r:id="Rd0d8c8f28276451e"/>
+    <p:sldMasterId xmlns:r="http://schemas.openxmlformats.org/officeDocument/2006/relationships" id="2147483648" r:id="Ra1371a3ce10d44d0"/>
   </p:sldMasterIdLst>
   <p:notesMasterIdLst>
-    <p:notesMasterId xmlns:r="http://schemas.openxmlformats.org/officeDocument/2006/relationships" r:id="R6e1aedb70a1a4148"/>
+    <p:notesMasterId xmlns:r="http://schemas.openxmlformats.org/officeDocument/2006/relationships" r:id="Rc8c1c974e56b4306"/>
   </p:notesMasterIdLst>
   <p:sldIdLst>
-    <p:sldId xmlns:r="http://schemas.openxmlformats.org/officeDocument/2006/relationships" id="256" r:id="R31014305a5ad4b9f"/>
-    <p:sldId xmlns:r="http://schemas.openxmlformats.org/officeDocument/2006/relationships" id="257" r:id="Rc8ff9f2b361b455d"/>
-    <p:sldId xmlns:r="http://schemas.openxmlformats.org/officeDocument/2006/relationships" id="258" r:id="Rb0b132a5712d43a7"/>
-    <p:sldId xmlns:r="http://schemas.openxmlformats.org/officeDocument/2006/relationships" id="259" r:id="R19261e963aa44bbc"/>
-    <p:sldId xmlns:r="http://schemas.openxmlformats.org/officeDocument/2006/relationships" id="260" r:id="R2fc0b1b4b8bc444b"/>
-    <p:sldId xmlns:r="http://schemas.openxmlformats.org/officeDocument/2006/relationships" id="261" r:id="Ra398c870c4354796"/>
+    <p:sldId xmlns:r="http://schemas.openxmlformats.org/officeDocument/2006/relationships" id="256" r:id="Rf42f73b39dac4c49"/>
+    <p:sldId xmlns:r="http://schemas.openxmlformats.org/officeDocument/2006/relationships" id="257" r:id="Rc49edb43ca924f7d"/>
+    <p:sldId xmlns:r="http://schemas.openxmlformats.org/officeDocument/2006/relationships" id="258" r:id="R45a3bb44f95846e0"/>
+    <p:sldId xmlns:r="http://schemas.openxmlformats.org/officeDocument/2006/relationships" id="259" r:id="R4c10d95c5b8744b8"/>
+    <p:sldId xmlns:r="http://schemas.openxmlformats.org/officeDocument/2006/relationships" id="260" r:id="Rf08b8322557e4b1a"/>
+    <p:sldId xmlns:r="http://schemas.openxmlformats.org/officeDocument/2006/relationships" id="261" r:id="Rb64ac1273792495a"/>
   </p:sldIdLst>
   <p:sldSz cx="12192000" cy="6858000"/>
   <p:notesSz cx="6858000" cy="9144000"/>
@@ -447,7 +447,7 @@
           <a:lstStyle xmlns:a="http://schemas.openxmlformats.org/drawingml/2006/main"/>
           <a:p xmlns:a="http://schemas.openxmlformats.org/drawingml/2006/main">
             <a:r>
-              <a:t>Open with the central design choice: plan facts and recommendations come from rules; the local model is optional.</a:t>
+              <a:t>Open with the central design choice: rules own the diagnosis and plan evidence; local AI uses retrieved sources to explain the finding.</a:t>
             </a:r>
           </a:p>
           <a:p xmlns:a="http://schemas.openxmlformats.org/drawingml/2006/main">
@@ -537,7 +537,7 @@
           <a:lstStyle xmlns:a="http://schemas.openxmlformats.org/drawingml/2006/main"/>
           <a:p xmlns:a="http://schemas.openxmlformats.org/drawingml/2006/main">
             <a:r>
-              <a:t>Walk left to right. The first API response is complete before retrieval or inference begins.</a:t>
+              <a:t>Walk left to right. The deterministic diagnosis is complete before retrieval or inference. AI enrichment is a separate grounded step.</a:t>
             </a:r>
           </a:p>
           <a:p xmlns:a="http://schemas.openxmlformats.org/drawingml/2006/main">
@@ -627,7 +627,7 @@
           <a:lstStyle xmlns:a="http://schemas.openxmlformats.org/drawingml/2006/main"/>
           <a:p xmlns:a="http://schemas.openxmlformats.org/drawingml/2006/main">
             <a:r>
-              <a:t>Contrast the full engineering runtime with the deployable portfolio surface. Neither runtime lets the model create evidence or citations.</a:t>
+              <a:t>Contrast the full engineering runtime with the public browser demo. The model generates prose locally, but it cannot create plan evidence or citation IDs.</a:t>
             </a:r>
           </a:p>
           <a:p xmlns:a="http://schemas.openxmlformats.org/drawingml/2006/main">
@@ -717,7 +717,7 @@
           <a:lstStyle xmlns:a="http://schemas.openxmlformats.org/drawingml/2006/main"/>
           <a:p xmlns:a="http://schemas.openxmlformats.org/drawingml/2006/main">
             <a:r>
-              <a:t>Stress that the language model cannot author technical prose. If rule evidence is absent, the system returns no clear issue.</a:t>
+              <a:t>The model may write technical prose only after plan evidence and category-supporting RAG chunks exist. Unknown IDs or invented facts are rejected.</a:t>
             </a:r>
           </a:p>
           <a:p xmlns:a="http://schemas.openxmlformats.org/drawingml/2006/main">
@@ -812,7 +812,7 @@
           <a:lstStyle xmlns:a="http://schemas.openxmlformats.org/drawingml/2006/main"/>
           <a:p xmlns:a="http://schemas.openxmlformats.org/drawingml/2006/main">
             <a:r>
-              <a:t>These are MVP fixture results, not production benchmarks. The 20,243 ms average is the reason inference is off the primary path.</a:t>
+              <a:t>These are fixture results, not production benchmarks. Grounded generation passed 4/4 evaluated cases; 48,256 ms average CPU latency keeps inference off the primary path.</a:t>
             </a:r>
           </a:p>
           <a:p xmlns:a="http://schemas.openxmlformats.org/drawingml/2006/main">
@@ -827,7 +827,7 @@
           </a:p>
           <a:p xmlns:a="http://schemas.openxmlformats.org/drawingml/2006/main">
             <a:r>
-              <a:t>- C:\Users\Eray\SEZAR\PROJECTS\QueryPilot\evaluation\results_qwen2.5-1.5b.json</a:t>
+              <a:t>- C:\Users\Eray\SEZAR\PROJECTS\QueryPilot\evaluation\results.json</a:t>
             </a:r>
           </a:p>
           <a:p xmlns:a="http://schemas.openxmlformats.org/drawingml/2006/main">
@@ -902,7 +902,7 @@
           <a:lstStyle xmlns:a="http://schemas.openxmlformats.org/drawingml/2006/main"/>
           <a:p xmlns:a="http://schemas.openxmlformats.org/drawingml/2006/main">
             <a:r>
-              <a:t>Close with the measured plan change, then state the boundary: this is a local synthetic fixture, not a production performance guarantee. The five-minute demo video remains the final manual release artefact.</a:t>
+              <a:t>Close with measured plan evidence, grounded AI proof, and the remaining boundary: this is a local synthetic fixture, not a production performance guarantee.</a:t>
             </a:r>
           </a:p>
           <a:p xmlns:a="http://schemas.openxmlformats.org/drawingml/2006/main">
@@ -922,12 +922,12 @@
           </a:p>
           <a:p xmlns:a="http://schemas.openxmlformats.org/drawingml/2006/main">
             <a:r>
-              <a:t>- C:\Users\Eray\SEZAR\PROJECTS\QueryPilot\docs\demo-script.md</a:t>
-            </a:r>
-          </a:p>
-          <a:p xmlns:a="http://schemas.openxmlformats.org/drawingml/2006/main">
-            <a:r>
-              <a:t>- C:\Users\Eray\SEZAR\PROJECTS\QueryPilot\docs\architecture.md</a:t>
+              <a:t>- C:\Users\Eray\SEZAR\PROJECTS\QueryPilot\evaluation\results.json</a:t>
+            </a:r>
+          </a:p>
+          <a:p xmlns:a="http://schemas.openxmlformats.org/drawingml/2006/main">
+            <a:r>
+              <a:t>- C:\Users\Eray\SEZAR\PROJECTS\QueryPilot\docs\v2-beta.md</a:t>
             </a:r>
           </a:p>
         </p:txBody>
@@ -995,7 +995,7 @@
   </p:cSld>
   <p:clrMap bg1="lt1" tx1="dk1" bg2="lt2" tx2="dk2" accent1="accent1" accent2="accent2" accent3="accent3" accent4="accent4" accent5="accent5" accent6="accent6" hlink="hlink" folHlink="folHlink"/>
   <p:sldLayoutIdLst>
-    <p:sldLayoutId xmlns:r="http://schemas.openxmlformats.org/officeDocument/2006/relationships" id="2147483649" r:id="Rd9bfae554d434a20"/>
+    <p:sldLayoutId xmlns:r="http://schemas.openxmlformats.org/officeDocument/2006/relationships" id="2147483649" r:id="Rbfc335b3a8794eed"/>
   </p:sldLayoutIdLst>
   <p:txStyles>
     <p:titleStyle>
@@ -1576,7 +1576,7 @@
             </a:pPr>
             <a:r>
               <a:t>Evidence first.
-LLM second.</a:t>
+AI explains.</a:t>
             </a:r>
           </a:p>
         </p:txBody>
@@ -1622,7 +1622,7 @@
               </a:defRPr>
             </a:pPr>
             <a:r>
-              <a:t>Offline PostgreSQL plan analysis with a deterministic correctness path.</a:t>
+              <a:t>Offline PostgreSQL plan analysis with deterministic rules, local RAG and grounded AI.</a:t>
             </a:r>
           </a:p>
         </p:txBody>
@@ -1811,14 +1811,14 @@
               </a:defRPr>
             </a:pPr>
             <a:r>
-              <a:t>The fast path ends before the model starts</a:t>
+              <a:t>The diagnosis is complete before the model starts</a:t>
             </a:r>
           </a:p>
         </p:txBody>
       </p:sp>
       <p:cxnSp>
         <p:nvCxnSpPr>
-          <p:cNvPr id="22" name="Google-Shape-2259-p159-4"/>
+          <p:cNvPr id="28" name="Google-Shape-2259-p159-4"/>
           <p:cNvCxnSpPr/>
           <p:nvPr/>
         </p:nvCxnSpPr>
@@ -2052,7 +2052,7 @@
               </a:defRPr>
             </a:pPr>
             <a:r>
-              <a:t>3. EXPLAIN</a:t>
+              <a:t>3. GROUND</a:t>
             </a:r>
           </a:p>
         </p:txBody>
@@ -2224,8 +2224,7 @@
               </a:defRPr>
             </a:pPr>
             <a:r>
-              <a:t>Optional wording
-</a:t>
+              <a:t>Grounded AI</a:t>
             </a:r>
           </a:p>
           <a:p xmlns:a="http://schemas.openxmlformats.org/drawingml/2006/main">
@@ -2241,7 +2240,23 @@
               </a:defRPr>
             </a:pPr>
             <a:r>
-              <a:t>Retrieve docs + select approved sentences</a:t>
+              <a:t/>
+            </a:r>
+          </a:p>
+          <a:p xmlns:a="http://schemas.openxmlformats.org/drawingml/2006/main">
+            <a:pPr algn="l">
+              <a:buNone/>
+              <a:defRPr sz="2400">
+                <a:solidFill>
+                  <a:srgbClr val="000000"/>
+                </a:solidFill>
+                <a:latin typeface="Helvetica Neue"/>
+                <a:ea typeface="Helvetica Neue"/>
+                <a:cs typeface="Helvetica Neue"/>
+              </a:defRPr>
+            </a:pPr>
+            <a:r>
+              <a:t>Retrieve chunks + generate evidence-bound prose</a:t>
             </a:r>
           </a:p>
         </p:txBody>
@@ -2386,7 +2401,7 @@
               </a:defRPr>
             </a:pPr>
             <a:r>
-              <a:t>Two runtimes share one trust boundary</a:t>
+              <a:t>Local AI + RAG extends the deterministic core</a:t>
             </a:r>
           </a:p>
         </p:txBody>
@@ -2616,7 +2631,7 @@
               </a:defRPr>
             </a:pPr>
             <a:r>
-              <a:t>Local RAG + sentence IDs</a:t>
+              <a:t>RAG chunks + grounded AI prose</a:t>
             </a:r>
           </a:p>
         </p:txBody>
@@ -2800,8 +2815,7 @@
               </a:defRPr>
             </a:pPr>
             <a:r>
-              <a:t>LOCAL RUNTIME
-</a:t>
+              <a:t>LOCAL RUNTIME</a:t>
             </a:r>
           </a:p>
           <a:p xmlns:a="http://schemas.openxmlformats.org/drawingml/2006/main">
@@ -2817,8 +2831,7 @@
               </a:defRPr>
             </a:pPr>
             <a:r>
-              <a:t>PostgreSQL + FastAPI + rules + optional Foundry.
-</a:t>
+              <a:t/>
             </a:r>
           </a:p>
           <a:p xmlns:a="http://schemas.openxmlformats.org/drawingml/2006/main">
@@ -2834,8 +2847,71 @@
               </a:defRPr>
             </a:pPr>
             <a:r>
-              <a:t>PUBLIC DEMO
-Browser-only plan JSON; no database or model.</a:t>
+              <a:t>PostgreSQL + FastAPI + rules + RAG + Foundry.</a:t>
+            </a:r>
+          </a:p>
+          <a:p xmlns:a="http://schemas.openxmlformats.org/drawingml/2006/main">
+            <a:pPr algn="l">
+              <a:buNone/>
+              <a:defRPr sz="2400">
+                <a:solidFill>
+                  <a:srgbClr val="000000"/>
+                </a:solidFill>
+                <a:latin typeface="Helvetica Neue"/>
+                <a:ea typeface="Helvetica Neue"/>
+                <a:cs typeface="Helvetica Neue"/>
+              </a:defRPr>
+            </a:pPr>
+            <a:r>
+              <a:t/>
+            </a:r>
+          </a:p>
+          <a:p xmlns:a="http://schemas.openxmlformats.org/drawingml/2006/main">
+            <a:pPr algn="l">
+              <a:buNone/>
+              <a:defRPr sz="2400">
+                <a:solidFill>
+                  <a:srgbClr val="000000"/>
+                </a:solidFill>
+                <a:latin typeface="Helvetica Neue"/>
+                <a:ea typeface="Helvetica Neue"/>
+                <a:cs typeface="Helvetica Neue"/>
+              </a:defRPr>
+            </a:pPr>
+            <a:r>
+              <a:t/>
+            </a:r>
+          </a:p>
+          <a:p xmlns:a="http://schemas.openxmlformats.org/drawingml/2006/main">
+            <a:pPr algn="l">
+              <a:buNone/>
+              <a:defRPr sz="2400">
+                <a:solidFill>
+                  <a:srgbClr val="000000"/>
+                </a:solidFill>
+                <a:latin typeface="Helvetica Neue"/>
+                <a:ea typeface="Helvetica Neue"/>
+                <a:cs typeface="Helvetica Neue"/>
+              </a:defRPr>
+            </a:pPr>
+            <a:r>
+              <a:t>PUBLIC DEMO</a:t>
+            </a:r>
+          </a:p>
+          <a:p xmlns:a="http://schemas.openxmlformats.org/drawingml/2006/main">
+            <a:pPr algn="l">
+              <a:buNone/>
+              <a:defRPr sz="2400">
+                <a:solidFill>
+                  <a:srgbClr val="000000"/>
+                </a:solidFill>
+                <a:latin typeface="Helvetica Neue"/>
+                <a:ea typeface="Helvetica Neue"/>
+                <a:cs typeface="Helvetica Neue"/>
+              </a:defRPr>
+            </a:pPr>
+            <a:r>
+              <a:t>Browser-only plan JSON; no database or model.</a:t>
             </a:r>
           </a:p>
         </p:txBody>
@@ -2980,7 +3056,7 @@
               </a:defRPr>
             </a:pPr>
             <a:r>
-              <a:t>No evidence means no recommendation</a:t>
+              <a:t>No evidence, no AI recommendation</a:t>
             </a:r>
           </a:p>
         </p:txBody>
@@ -3026,7 +3102,7 @@
               </a:defRPr>
             </a:pPr>
             <a:r>
-              <a:t>Reliability is enforced in code</a:t>
+              <a:t>Reliability is enforced before and after generation</a:t>
             </a:r>
           </a:p>
         </p:txBody>
@@ -3242,7 +3318,7 @@
               </a:defRPr>
             </a:pPr>
             <a:r>
-              <a:t>Category, severity, plan evidence, SQL and citations are application-owned.</a:t>
+              <a:t>Category, severity, raw plan evidence and recommendation SQL are application-owned.</a:t>
             </a:r>
           </a:p>
           <a:p xmlns:a="http://schemas.openxmlformats.org/drawingml/2006/main">
@@ -3258,7 +3334,7 @@
               </a:defRPr>
             </a:pPr>
             <a:r>
-              <a:t>Unknown IDs, invented citations, extra prose and malformed output fall back safely.</a:t>
+              <a:t>Generated prose must reference known evidence and retrieved chunk IDs. Invented metrics, identifiers or citations fall back safely.</a:t>
             </a:r>
           </a:p>
         </p:txBody>
@@ -3474,7 +3550,7 @@
               </a:defRPr>
             </a:pPr>
             <a:r>
-              <a:t>Unknown citations rejected</a:t>
+              <a:t>Retrieved citation IDs only</a:t>
             </a:r>
           </a:p>
         </p:txBody>
@@ -3628,7 +3704,7 @@
         </p:spPr>
         <p:txBody>
           <a:bodyPr xmlns:a="http://schemas.openxmlformats.org/drawingml/2006/main" lIns="0" tIns="0" rIns="0" bIns="0">
-            <a:normAutofit fontScale="86323"/>
+            <a:normAutofit fontScale="78830"/>
           </a:bodyPr>
           <a:lstStyle xmlns:a="http://schemas.openxmlformats.org/drawingml/2006/main"/>
           <a:p xmlns:a="http://schemas.openxmlformats.org/drawingml/2006/main">
@@ -3644,7 +3720,7 @@
               </a:defRPr>
             </a:pPr>
             <a:r>
-              <a:t>Recommendation SQL is display-only</a:t>
+              <a:t>Recommendation SQL stays display-only</a:t>
             </a:r>
           </a:p>
         </p:txBody>
@@ -4168,7 +4244,7 @@
               </a:defRPr>
             </a:pPr>
             <a:r>
-              <a:t>The MVP fixtures pass; CPU enrichment stays optional</a:t>
+              <a:t>Grounded AI passes 4/4; CPU latency stays optional</a:t>
             </a:r>
           </a:p>
         </p:txBody>
@@ -4262,7 +4338,7 @@
             </a:pPr>
             <a:r>
               <a:t>Average optional
-CPU selection</a:t>
+CPU generation</a:t>
             </a:r>
           </a:p>
         </p:txBody>
@@ -4447,7 +4523,7 @@
               </a:defRPr>
             </a:pPr>
             <a:r>
-              <a:t>20.2 s</a:t>
+              <a:t>48.3 s</a:t>
             </a:r>
           </a:p>
         </p:txBody>
@@ -4493,8 +4569,7 @@
               </a:defRPr>
             </a:pPr>
             <a:r>
-              <a:t>MEASURED RESULT
-</a:t>
+              <a:t>MEASURED RESULT</a:t>
             </a:r>
           </a:p>
           <a:p xmlns:a="http://schemas.openxmlformats.org/drawingml/2006/main">
@@ -4510,7 +4585,23 @@
               </a:defRPr>
             </a:pPr>
             <a:r>
-              <a:t>12 committed scenarios. Citations were valid in 4/4 generation samples; the 1.5B selector was accepted in 4/4.</a:t>
+              <a:t/>
+            </a:r>
+          </a:p>
+          <a:p xmlns:a="http://schemas.openxmlformats.org/drawingml/2006/main">
+            <a:pPr algn="l">
+              <a:buNone/>
+              <a:defRPr sz="1600">
+                <a:solidFill>
+                  <a:srgbClr val="000000"/>
+                </a:solidFill>
+                <a:latin typeface="Helvetica Neue"/>
+                <a:ea typeface="Helvetica Neue"/>
+                <a:cs typeface="Helvetica Neue"/>
+              </a:defRPr>
+            </a:pPr>
+            <a:r>
+              <a:t>12 committed scenarios. Rule and no-answer: 12/12; retrieval Hit@3: 9/9; grounded reports and citations: 4/4.</a:t>
             </a:r>
           </a:p>
         </p:txBody>
@@ -4610,7 +4701,7 @@
             </a:pPr>
             <a:r>
               <a:t>Proof measured.
-Limits explicit.</a:t>
+AI grounded.</a:t>
             </a:r>
           </a:p>
         </p:txBody>
@@ -4672,7 +4763,7 @@
               </a:defRPr>
             </a:pPr>
             <a:r>
-              <a:t>Local fixture only · optional CPU enrichment</a:t>
+              <a:t>Grounded generation 4/4 · valid citations 4/4 · CPU average 48.3 s</a:t>
             </a:r>
           </a:p>
           <a:p xmlns:a="http://schemas.openxmlformats.org/drawingml/2006/main">
@@ -4688,7 +4779,7 @@
               </a:defRPr>
             </a:pPr>
             <a:r>
-              <a:t>Next: tool-calling v2 · querypilot.eraykulkizaga.com</a:t>
+              <a:t>Local fixture only · next: authorized non-production pilot</a:t>
             </a:r>
           </a:p>
         </p:txBody>

</xml_diff>

<commit_message>
Release grounded AI beta 2 (#5)
</commit_message>
<xml_diff>
--- a/artifacts/QueryPilot_Local_Teknik_Sunum.pptx
+++ b/artifacts/QueryPilot_Local_Teknik_Sunum.pptx
@@ -2,18 +2,18 @@
 <file path=ppt/presentation.xml><?xml version="1.0" encoding="utf-8"?>
 <p:presentation xmlns:p="http://schemas.openxmlformats.org/presentationml/2006/main">
   <p:sldMasterIdLst>
-    <p:sldMasterId xmlns:r="http://schemas.openxmlformats.org/officeDocument/2006/relationships" id="2147483648" r:id="Rd0d8c8f28276451e"/>
+    <p:sldMasterId xmlns:r="http://schemas.openxmlformats.org/officeDocument/2006/relationships" id="2147483648" r:id="Ra1371a3ce10d44d0"/>
   </p:sldMasterIdLst>
   <p:notesMasterIdLst>
-    <p:notesMasterId xmlns:r="http://schemas.openxmlformats.org/officeDocument/2006/relationships" r:id="R6e1aedb70a1a4148"/>
+    <p:notesMasterId xmlns:r="http://schemas.openxmlformats.org/officeDocument/2006/relationships" r:id="Rc8c1c974e56b4306"/>
   </p:notesMasterIdLst>
   <p:sldIdLst>
-    <p:sldId xmlns:r="http://schemas.openxmlformats.org/officeDocument/2006/relationships" id="256" r:id="R31014305a5ad4b9f"/>
-    <p:sldId xmlns:r="http://schemas.openxmlformats.org/officeDocument/2006/relationships" id="257" r:id="Rc8ff9f2b361b455d"/>
-    <p:sldId xmlns:r="http://schemas.openxmlformats.org/officeDocument/2006/relationships" id="258" r:id="Rb0b132a5712d43a7"/>
-    <p:sldId xmlns:r="http://schemas.openxmlformats.org/officeDocument/2006/relationships" id="259" r:id="R19261e963aa44bbc"/>
-    <p:sldId xmlns:r="http://schemas.openxmlformats.org/officeDocument/2006/relationships" id="260" r:id="R2fc0b1b4b8bc444b"/>
-    <p:sldId xmlns:r="http://schemas.openxmlformats.org/officeDocument/2006/relationships" id="261" r:id="Ra398c870c4354796"/>
+    <p:sldId xmlns:r="http://schemas.openxmlformats.org/officeDocument/2006/relationships" id="256" r:id="Rf42f73b39dac4c49"/>
+    <p:sldId xmlns:r="http://schemas.openxmlformats.org/officeDocument/2006/relationships" id="257" r:id="Rc49edb43ca924f7d"/>
+    <p:sldId xmlns:r="http://schemas.openxmlformats.org/officeDocument/2006/relationships" id="258" r:id="R45a3bb44f95846e0"/>
+    <p:sldId xmlns:r="http://schemas.openxmlformats.org/officeDocument/2006/relationships" id="259" r:id="R4c10d95c5b8744b8"/>
+    <p:sldId xmlns:r="http://schemas.openxmlformats.org/officeDocument/2006/relationships" id="260" r:id="Rf08b8322557e4b1a"/>
+    <p:sldId xmlns:r="http://schemas.openxmlformats.org/officeDocument/2006/relationships" id="261" r:id="Rb64ac1273792495a"/>
   </p:sldIdLst>
   <p:sldSz cx="12192000" cy="6858000"/>
   <p:notesSz cx="6858000" cy="9144000"/>
@@ -447,7 +447,7 @@
           <a:lstStyle xmlns:a="http://schemas.openxmlformats.org/drawingml/2006/main"/>
           <a:p xmlns:a="http://schemas.openxmlformats.org/drawingml/2006/main">
             <a:r>
-              <a:t>Open with the central design choice: plan facts and recommendations come from rules; the local model is optional.</a:t>
+              <a:t>Open with the central design choice: rules own the diagnosis and plan evidence; local AI uses retrieved sources to explain the finding.</a:t>
             </a:r>
           </a:p>
           <a:p xmlns:a="http://schemas.openxmlformats.org/drawingml/2006/main">
@@ -537,7 +537,7 @@
           <a:lstStyle xmlns:a="http://schemas.openxmlformats.org/drawingml/2006/main"/>
           <a:p xmlns:a="http://schemas.openxmlformats.org/drawingml/2006/main">
             <a:r>
-              <a:t>Walk left to right. The first API response is complete before retrieval or inference begins.</a:t>
+              <a:t>Walk left to right. The deterministic diagnosis is complete before retrieval or inference. AI enrichment is a separate grounded step.</a:t>
             </a:r>
           </a:p>
           <a:p xmlns:a="http://schemas.openxmlformats.org/drawingml/2006/main">
@@ -627,7 +627,7 @@
           <a:lstStyle xmlns:a="http://schemas.openxmlformats.org/drawingml/2006/main"/>
           <a:p xmlns:a="http://schemas.openxmlformats.org/drawingml/2006/main">
             <a:r>
-              <a:t>Contrast the full engineering runtime with the deployable portfolio surface. Neither runtime lets the model create evidence or citations.</a:t>
+              <a:t>Contrast the full engineering runtime with the public browser demo. The model generates prose locally, but it cannot create plan evidence or citation IDs.</a:t>
             </a:r>
           </a:p>
           <a:p xmlns:a="http://schemas.openxmlformats.org/drawingml/2006/main">
@@ -717,7 +717,7 @@
           <a:lstStyle xmlns:a="http://schemas.openxmlformats.org/drawingml/2006/main"/>
           <a:p xmlns:a="http://schemas.openxmlformats.org/drawingml/2006/main">
             <a:r>
-              <a:t>Stress that the language model cannot author technical prose. If rule evidence is absent, the system returns no clear issue.</a:t>
+              <a:t>The model may write technical prose only after plan evidence and category-supporting RAG chunks exist. Unknown IDs or invented facts are rejected.</a:t>
             </a:r>
           </a:p>
           <a:p xmlns:a="http://schemas.openxmlformats.org/drawingml/2006/main">
@@ -812,7 +812,7 @@
           <a:lstStyle xmlns:a="http://schemas.openxmlformats.org/drawingml/2006/main"/>
           <a:p xmlns:a="http://schemas.openxmlformats.org/drawingml/2006/main">
             <a:r>
-              <a:t>These are MVP fixture results, not production benchmarks. The 20,243 ms average is the reason inference is off the primary path.</a:t>
+              <a:t>These are fixture results, not production benchmarks. Grounded generation passed 4/4 evaluated cases; 48,256 ms average CPU latency keeps inference off the primary path.</a:t>
             </a:r>
           </a:p>
           <a:p xmlns:a="http://schemas.openxmlformats.org/drawingml/2006/main">
@@ -827,7 +827,7 @@
           </a:p>
           <a:p xmlns:a="http://schemas.openxmlformats.org/drawingml/2006/main">
             <a:r>
-              <a:t>- C:\Users\Eray\SEZAR\PROJECTS\QueryPilot\evaluation\results_qwen2.5-1.5b.json</a:t>
+              <a:t>- C:\Users\Eray\SEZAR\PROJECTS\QueryPilot\evaluation\results.json</a:t>
             </a:r>
           </a:p>
           <a:p xmlns:a="http://schemas.openxmlformats.org/drawingml/2006/main">
@@ -902,7 +902,7 @@
           <a:lstStyle xmlns:a="http://schemas.openxmlformats.org/drawingml/2006/main"/>
           <a:p xmlns:a="http://schemas.openxmlformats.org/drawingml/2006/main">
             <a:r>
-              <a:t>Close with the measured plan change, then state the boundary: this is a local synthetic fixture, not a production performance guarantee. The five-minute demo video remains the final manual release artefact.</a:t>
+              <a:t>Close with measured plan evidence, grounded AI proof, and the remaining boundary: this is a local synthetic fixture, not a production performance guarantee.</a:t>
             </a:r>
           </a:p>
           <a:p xmlns:a="http://schemas.openxmlformats.org/drawingml/2006/main">
@@ -922,12 +922,12 @@
           </a:p>
           <a:p xmlns:a="http://schemas.openxmlformats.org/drawingml/2006/main">
             <a:r>
-              <a:t>- C:\Users\Eray\SEZAR\PROJECTS\QueryPilot\docs\demo-script.md</a:t>
-            </a:r>
-          </a:p>
-          <a:p xmlns:a="http://schemas.openxmlformats.org/drawingml/2006/main">
-            <a:r>
-              <a:t>- C:\Users\Eray\SEZAR\PROJECTS\QueryPilot\docs\architecture.md</a:t>
+              <a:t>- C:\Users\Eray\SEZAR\PROJECTS\QueryPilot\evaluation\results.json</a:t>
+            </a:r>
+          </a:p>
+          <a:p xmlns:a="http://schemas.openxmlformats.org/drawingml/2006/main">
+            <a:r>
+              <a:t>- C:\Users\Eray\SEZAR\PROJECTS\QueryPilot\docs\v2-beta.md</a:t>
             </a:r>
           </a:p>
         </p:txBody>
@@ -995,7 +995,7 @@
   </p:cSld>
   <p:clrMap bg1="lt1" tx1="dk1" bg2="lt2" tx2="dk2" accent1="accent1" accent2="accent2" accent3="accent3" accent4="accent4" accent5="accent5" accent6="accent6" hlink="hlink" folHlink="folHlink"/>
   <p:sldLayoutIdLst>
-    <p:sldLayoutId xmlns:r="http://schemas.openxmlformats.org/officeDocument/2006/relationships" id="2147483649" r:id="Rd9bfae554d434a20"/>
+    <p:sldLayoutId xmlns:r="http://schemas.openxmlformats.org/officeDocument/2006/relationships" id="2147483649" r:id="Rbfc335b3a8794eed"/>
   </p:sldLayoutIdLst>
   <p:txStyles>
     <p:titleStyle>
@@ -1576,7 +1576,7 @@
             </a:pPr>
             <a:r>
               <a:t>Evidence first.
-LLM second.</a:t>
+AI explains.</a:t>
             </a:r>
           </a:p>
         </p:txBody>
@@ -1622,7 +1622,7 @@
               </a:defRPr>
             </a:pPr>
             <a:r>
-              <a:t>Offline PostgreSQL plan analysis with a deterministic correctness path.</a:t>
+              <a:t>Offline PostgreSQL plan analysis with deterministic rules, local RAG and grounded AI.</a:t>
             </a:r>
           </a:p>
         </p:txBody>
@@ -1811,14 +1811,14 @@
               </a:defRPr>
             </a:pPr>
             <a:r>
-              <a:t>The fast path ends before the model starts</a:t>
+              <a:t>The diagnosis is complete before the model starts</a:t>
             </a:r>
           </a:p>
         </p:txBody>
       </p:sp>
       <p:cxnSp>
         <p:nvCxnSpPr>
-          <p:cNvPr id="22" name="Google-Shape-2259-p159-4"/>
+          <p:cNvPr id="28" name="Google-Shape-2259-p159-4"/>
           <p:cNvCxnSpPr/>
           <p:nvPr/>
         </p:nvCxnSpPr>
@@ -2052,7 +2052,7 @@
               </a:defRPr>
             </a:pPr>
             <a:r>
-              <a:t>3. EXPLAIN</a:t>
+              <a:t>3. GROUND</a:t>
             </a:r>
           </a:p>
         </p:txBody>
@@ -2224,8 +2224,7 @@
               </a:defRPr>
             </a:pPr>
             <a:r>
-              <a:t>Optional wording
-</a:t>
+              <a:t>Grounded AI</a:t>
             </a:r>
           </a:p>
           <a:p xmlns:a="http://schemas.openxmlformats.org/drawingml/2006/main">
@@ -2241,7 +2240,23 @@
               </a:defRPr>
             </a:pPr>
             <a:r>
-              <a:t>Retrieve docs + select approved sentences</a:t>
+              <a:t/>
+            </a:r>
+          </a:p>
+          <a:p xmlns:a="http://schemas.openxmlformats.org/drawingml/2006/main">
+            <a:pPr algn="l">
+              <a:buNone/>
+              <a:defRPr sz="2400">
+                <a:solidFill>
+                  <a:srgbClr val="000000"/>
+                </a:solidFill>
+                <a:latin typeface="Helvetica Neue"/>
+                <a:ea typeface="Helvetica Neue"/>
+                <a:cs typeface="Helvetica Neue"/>
+              </a:defRPr>
+            </a:pPr>
+            <a:r>
+              <a:t>Retrieve chunks + generate evidence-bound prose</a:t>
             </a:r>
           </a:p>
         </p:txBody>
@@ -2386,7 +2401,7 @@
               </a:defRPr>
             </a:pPr>
             <a:r>
-              <a:t>Two runtimes share one trust boundary</a:t>
+              <a:t>Local AI + RAG extends the deterministic core</a:t>
             </a:r>
           </a:p>
         </p:txBody>
@@ -2616,7 +2631,7 @@
               </a:defRPr>
             </a:pPr>
             <a:r>
-              <a:t>Local RAG + sentence IDs</a:t>
+              <a:t>RAG chunks + grounded AI prose</a:t>
             </a:r>
           </a:p>
         </p:txBody>
@@ -2800,8 +2815,7 @@
               </a:defRPr>
             </a:pPr>
             <a:r>
-              <a:t>LOCAL RUNTIME
-</a:t>
+              <a:t>LOCAL RUNTIME</a:t>
             </a:r>
           </a:p>
           <a:p xmlns:a="http://schemas.openxmlformats.org/drawingml/2006/main">
@@ -2817,8 +2831,7 @@
               </a:defRPr>
             </a:pPr>
             <a:r>
-              <a:t>PostgreSQL + FastAPI + rules + optional Foundry.
-</a:t>
+              <a:t/>
             </a:r>
           </a:p>
           <a:p xmlns:a="http://schemas.openxmlformats.org/drawingml/2006/main">
@@ -2834,8 +2847,71 @@
               </a:defRPr>
             </a:pPr>
             <a:r>
-              <a:t>PUBLIC DEMO
-Browser-only plan JSON; no database or model.</a:t>
+              <a:t>PostgreSQL + FastAPI + rules + RAG + Foundry.</a:t>
+            </a:r>
+          </a:p>
+          <a:p xmlns:a="http://schemas.openxmlformats.org/drawingml/2006/main">
+            <a:pPr algn="l">
+              <a:buNone/>
+              <a:defRPr sz="2400">
+                <a:solidFill>
+                  <a:srgbClr val="000000"/>
+                </a:solidFill>
+                <a:latin typeface="Helvetica Neue"/>
+                <a:ea typeface="Helvetica Neue"/>
+                <a:cs typeface="Helvetica Neue"/>
+              </a:defRPr>
+            </a:pPr>
+            <a:r>
+              <a:t/>
+            </a:r>
+          </a:p>
+          <a:p xmlns:a="http://schemas.openxmlformats.org/drawingml/2006/main">
+            <a:pPr algn="l">
+              <a:buNone/>
+              <a:defRPr sz="2400">
+                <a:solidFill>
+                  <a:srgbClr val="000000"/>
+                </a:solidFill>
+                <a:latin typeface="Helvetica Neue"/>
+                <a:ea typeface="Helvetica Neue"/>
+                <a:cs typeface="Helvetica Neue"/>
+              </a:defRPr>
+            </a:pPr>
+            <a:r>
+              <a:t/>
+            </a:r>
+          </a:p>
+          <a:p xmlns:a="http://schemas.openxmlformats.org/drawingml/2006/main">
+            <a:pPr algn="l">
+              <a:buNone/>
+              <a:defRPr sz="2400">
+                <a:solidFill>
+                  <a:srgbClr val="000000"/>
+                </a:solidFill>
+                <a:latin typeface="Helvetica Neue"/>
+                <a:ea typeface="Helvetica Neue"/>
+                <a:cs typeface="Helvetica Neue"/>
+              </a:defRPr>
+            </a:pPr>
+            <a:r>
+              <a:t>PUBLIC DEMO</a:t>
+            </a:r>
+          </a:p>
+          <a:p xmlns:a="http://schemas.openxmlformats.org/drawingml/2006/main">
+            <a:pPr algn="l">
+              <a:buNone/>
+              <a:defRPr sz="2400">
+                <a:solidFill>
+                  <a:srgbClr val="000000"/>
+                </a:solidFill>
+                <a:latin typeface="Helvetica Neue"/>
+                <a:ea typeface="Helvetica Neue"/>
+                <a:cs typeface="Helvetica Neue"/>
+              </a:defRPr>
+            </a:pPr>
+            <a:r>
+              <a:t>Browser-only plan JSON; no database or model.</a:t>
             </a:r>
           </a:p>
         </p:txBody>
@@ -2980,7 +3056,7 @@
               </a:defRPr>
             </a:pPr>
             <a:r>
-              <a:t>No evidence means no recommendation</a:t>
+              <a:t>No evidence, no AI recommendation</a:t>
             </a:r>
           </a:p>
         </p:txBody>
@@ -3026,7 +3102,7 @@
               </a:defRPr>
             </a:pPr>
             <a:r>
-              <a:t>Reliability is enforced in code</a:t>
+              <a:t>Reliability is enforced before and after generation</a:t>
             </a:r>
           </a:p>
         </p:txBody>
@@ -3242,7 +3318,7 @@
               </a:defRPr>
             </a:pPr>
             <a:r>
-              <a:t>Category, severity, plan evidence, SQL and citations are application-owned.</a:t>
+              <a:t>Category, severity, raw plan evidence and recommendation SQL are application-owned.</a:t>
             </a:r>
           </a:p>
           <a:p xmlns:a="http://schemas.openxmlformats.org/drawingml/2006/main">
@@ -3258,7 +3334,7 @@
               </a:defRPr>
             </a:pPr>
             <a:r>
-              <a:t>Unknown IDs, invented citations, extra prose and malformed output fall back safely.</a:t>
+              <a:t>Generated prose must reference known evidence and retrieved chunk IDs. Invented metrics, identifiers or citations fall back safely.</a:t>
             </a:r>
           </a:p>
         </p:txBody>
@@ -3474,7 +3550,7 @@
               </a:defRPr>
             </a:pPr>
             <a:r>
-              <a:t>Unknown citations rejected</a:t>
+              <a:t>Retrieved citation IDs only</a:t>
             </a:r>
           </a:p>
         </p:txBody>
@@ -3628,7 +3704,7 @@
         </p:spPr>
         <p:txBody>
           <a:bodyPr xmlns:a="http://schemas.openxmlformats.org/drawingml/2006/main" lIns="0" tIns="0" rIns="0" bIns="0">
-            <a:normAutofit fontScale="86323"/>
+            <a:normAutofit fontScale="78830"/>
           </a:bodyPr>
           <a:lstStyle xmlns:a="http://schemas.openxmlformats.org/drawingml/2006/main"/>
           <a:p xmlns:a="http://schemas.openxmlformats.org/drawingml/2006/main">
@@ -3644,7 +3720,7 @@
               </a:defRPr>
             </a:pPr>
             <a:r>
-              <a:t>Recommendation SQL is display-only</a:t>
+              <a:t>Recommendation SQL stays display-only</a:t>
             </a:r>
           </a:p>
         </p:txBody>
@@ -4168,7 +4244,7 @@
               </a:defRPr>
             </a:pPr>
             <a:r>
-              <a:t>The MVP fixtures pass; CPU enrichment stays optional</a:t>
+              <a:t>Grounded AI passes 4/4; CPU latency stays optional</a:t>
             </a:r>
           </a:p>
         </p:txBody>
@@ -4262,7 +4338,7 @@
             </a:pPr>
             <a:r>
               <a:t>Average optional
-CPU selection</a:t>
+CPU generation</a:t>
             </a:r>
           </a:p>
         </p:txBody>
@@ -4447,7 +4523,7 @@
               </a:defRPr>
             </a:pPr>
             <a:r>
-              <a:t>20.2 s</a:t>
+              <a:t>48.3 s</a:t>
             </a:r>
           </a:p>
         </p:txBody>
@@ -4493,8 +4569,7 @@
               </a:defRPr>
             </a:pPr>
             <a:r>
-              <a:t>MEASURED RESULT
-</a:t>
+              <a:t>MEASURED RESULT</a:t>
             </a:r>
           </a:p>
           <a:p xmlns:a="http://schemas.openxmlformats.org/drawingml/2006/main">
@@ -4510,7 +4585,23 @@
               </a:defRPr>
             </a:pPr>
             <a:r>
-              <a:t>12 committed scenarios. Citations were valid in 4/4 generation samples; the 1.5B selector was accepted in 4/4.</a:t>
+              <a:t/>
+            </a:r>
+          </a:p>
+          <a:p xmlns:a="http://schemas.openxmlformats.org/drawingml/2006/main">
+            <a:pPr algn="l">
+              <a:buNone/>
+              <a:defRPr sz="1600">
+                <a:solidFill>
+                  <a:srgbClr val="000000"/>
+                </a:solidFill>
+                <a:latin typeface="Helvetica Neue"/>
+                <a:ea typeface="Helvetica Neue"/>
+                <a:cs typeface="Helvetica Neue"/>
+              </a:defRPr>
+            </a:pPr>
+            <a:r>
+              <a:t>12 committed scenarios. Rule and no-answer: 12/12; retrieval Hit@3: 9/9; grounded reports and citations: 4/4.</a:t>
             </a:r>
           </a:p>
         </p:txBody>
@@ -4610,7 +4701,7 @@
             </a:pPr>
             <a:r>
               <a:t>Proof measured.
-Limits explicit.</a:t>
+AI grounded.</a:t>
             </a:r>
           </a:p>
         </p:txBody>
@@ -4672,7 +4763,7 @@
               </a:defRPr>
             </a:pPr>
             <a:r>
-              <a:t>Local fixture only · optional CPU enrichment</a:t>
+              <a:t>Grounded generation 4/4 · valid citations 4/4 · CPU average 48.3 s</a:t>
             </a:r>
           </a:p>
           <a:p xmlns:a="http://schemas.openxmlformats.org/drawingml/2006/main">
@@ -4688,7 +4779,7 @@
               </a:defRPr>
             </a:pPr>
             <a:r>
-              <a:t>Next: tool-calling v2 · querypilot.eraykulkizaga.com</a:t>
+              <a:t>Local fixture only · next: authorized non-production pilot</a:t>
             </a:r>
           </a:p>
         </p:txBody>

</xml_diff>